<commit_message>
Juster pitch-decket til levert funksjonalitet (avklaring 8 og G8)
Slide 5: «Bygget og pilotert» blir «Bygget og klar for pilot» -
piloten er neste steg, ikke historie. Slide 6: «Kort møte bookes
direkte» blir «avtales direkte» - booking er utenfor scope. Slide
7: gårdeier-boksen merket som veikart, med ærlig tekst om at
fornyelsesgrad, frafall og lokalbruk bor i drifts- og
leiesystemene. Slide 12: «Der vi står» oppdatert - plugin bygget
og verifisert (fase 1-4 pluss samtykkeflyt, utfall, rapport og
ubesvart-løkke), lisens valgt, fase 1-2 og 3-4 markert levert.
PDF-en regenerert fra det justerte decket. Kun tekstendringer -
layout og design urørt (validert mot originalen, alle fire slides
visuelt kontrollert).

Co-Authored-By: Claude Fable 5 <noreply@anthropic.com>
Claude-Session: https://claude.ai/code/session_01UhQiATMJ5Gk16e4rsBXdNg
</commit_message>
<xml_diff>
--- a/samlabpitch.pptx
+++ b/samlabpitch.pptx
@@ -3654,7 +3654,7 @@
                 <a:ea typeface="Arial" pitchFamily="34" charset="-122"/>
                 <a:cs typeface="Arial" pitchFamily="34" charset="-120"/>
               </a:rPr>
-              <a:t>Vedtatt plugin-arkitektur og faseplan</a:t>
+              <a:t>Plugin bygget og verifisert: fase 1-4 pluss samtykkeflyt, utfall, rapport og ubesvart-løkke</a:t>
             </a:r>
             <a:endParaRPr lang="en-US" sz="1250" dirty="0"/>
           </a:p>
@@ -3822,7 +3822,7 @@
                 <a:ea typeface="Arial" pitchFamily="34" charset="-122"/>
                 <a:cs typeface="Arial" pitchFamily="34" charset="-120"/>
               </a:rPr>
-              <a:t>MVP: 3-5 ukers utvikling. Full pakke inkl. kontrollpanel og assistent: 5-8 uker.</a:t>
+              <a:t>Full pakke er bygget og verifisert - kontrollpanel, rapport og assistent inkludert.</a:t>
             </a:r>
             <a:endParaRPr lang="en-US" sz="1200" dirty="0"/>
           </a:p>
@@ -3964,7 +3964,7 @@
                 <a:ea typeface="Arial" pitchFamily="34" charset="-122"/>
                 <a:cs typeface="Arial" pitchFamily="34" charset="-120"/>
               </a:rPr>
-              <a:t>lisensmodell og tekniske avklaringer</a:t>
+              <a:t>lisens valgt (GPL) - pris og distribusjon gjenstår</a:t>
             </a:r>
             <a:endParaRPr lang="en-US" sz="1100" dirty="0"/>
           </a:p>
@@ -4067,7 +4067,7 @@
                 <a:ea typeface="Arial" pitchFamily="34" charset="-122"/>
                 <a:cs typeface="Arial" pitchFamily="34" charset="-120"/>
               </a:rPr>
-              <a:t>plugin-fundament + kjernen: profiler, behov &amp; tilbud, vegg, håndbok</a:t>
+              <a:t>plugin-fundament + kjernen: profiler, behov &amp; tilbud, vegg, håndbok - levert</a:t>
             </a:r>
             <a:endParaRPr lang="en-US" sz="1100" dirty="0"/>
           </a:p>
@@ -4273,7 +4273,7 @@
                 <a:ea typeface="Arial" pitchFamily="34" charset="-122"/>
                 <a:cs typeface="Arial" pitchFamily="34" charset="-120"/>
               </a:rPr>
-              <a:t>kontrollpanel, matching, lesebekreftelser, infoskjerm, assistent</a:t>
+              <a:t>kontrollpanel, matching, lesebekreftelser, infoskjerm, assistent - levert</a:t>
             </a:r>
             <a:endParaRPr lang="en-US" sz="1100" dirty="0"/>
           </a:p>
@@ -6952,7 +6952,7 @@
                 <a:ea typeface="Arial" pitchFamily="34" charset="-122"/>
                 <a:cs typeface="Arial" pitchFamily="34" charset="-120"/>
               </a:rPr>
-              <a:t>Bygget og pilotert hos Lius kunnskaps- og gründerhus</a:t>
+              <a:t>Bygget og klar for pilot hos Lius kunnskaps- og gründerhus</a:t>
             </a:r>
             <a:endParaRPr lang="en-US" sz="2700" dirty="0"/>
           </a:p>
@@ -8003,7 +8003,7 @@
                 <a:ea typeface="Arial" pitchFamily="34" charset="-122"/>
                 <a:cs typeface="Arial" pitchFamily="34" charset="-120"/>
               </a:rPr>
-              <a:t>Kort møte bookes direkte</a:t>
+              <a:t>Kort møte avtales direkte</a:t>
             </a:r>
             <a:endParaRPr lang="en-US" sz="1250" dirty="0"/>
           </a:p>
@@ -8609,7 +8609,7 @@
                 <a:ea typeface="Arial" pitchFamily="34" charset="-122"/>
                 <a:cs typeface="Arial" pitchFamily="34" charset="-120"/>
               </a:rPr>
-              <a:t>Verdi for gårdeier og operator</a:t>
+              <a:t>Verdi for gårdeier og operator (veikart)</a:t>
             </a:r>
             <a:endParaRPr lang="en-US" sz="1450" dirty="0"/>
           </a:p>
@@ -8651,7 +8651,7 @@
                 <a:ea typeface="Arial" pitchFamily="34" charset="-122"/>
                 <a:cs typeface="Arial" pitchFamily="34" charset="-120"/>
               </a:rPr>
-              <a:t>Fornyelsesgrad, frafall, bruk av lokaler og arrangementer - fellesskap som målbar leietakerlojalitet.</a:t>
+              <a:t>Fornyelsesgrad, frafall og lokalbruk bor i drifts- og leiesystemene - integrasjon på veikartet, ikke i portalen i dag.</a:t>
             </a:r>
             <a:endParaRPr lang="en-US" sz="1200" dirty="0"/>
           </a:p>

</xml_diff>